<commit_message>
덱 25장: Mac Docker 실행 캡처 3장(빌드 로그·docker ps healthy·컨테이너 Swagger 200) 반영
Co-Authored-By: Claude Fable 5.1 <noreply@anthropic.com>
Claude-Session: https://claude.ai/code/session_01BEjvKZ2gkJpwwFNKuqGgNg
</commit_message>
<xml_diff>
--- a/team_solar/release/해아림_발표.pptx
+++ b/team_solar/release/해아림_발표.pptx
@@ -2024,7 +2024,7 @@
           <a:p>
             <a:r>
               <a:rPr lang="en-US" dirty="0"/>
-              <a:t>이 장의 세 그림은 Docker Desktop이 있는 PC에서 캡처해 넣습니다. 빌드 로그에 GATE PASSED와 14 passed가 보이고, docker ps의 STATUS가 healthy가 되면 컨테이너의 /docs도 로컬과 같이 열립니다.</a:t>
+              <a:t>Mac에서 Docker Desktop으로 찍은 화면입니다. 빌드 마지막 RUN 단계가 시드 업로드, 모델 등록, 계약 테스트를 한 번에 돌리므로 그중 하나라도 실패하면 이미지가 만들어지지 않습니다. 컨테이너는 eager로 떠서 0.6초 만에 모델이 올라왔고, docker ps가 healthy가 된 뒤 Swagger에서 보낸 요청에 로컬과 똑같은 3,649.7 kWh를 돌려줬습니다.</a:t>
             </a:r>
             <a:endParaRPr lang="en-US" dirty="0"/>
           </a:p>
@@ -25459,7 +25459,7 @@
                 <a:ea typeface="Malgun Gothic" pitchFamily="34" charset="-122"/>
                 <a:cs typeface="Malgun Gothic" pitchFamily="34" charset="-120"/>
               </a:rPr>
-              <a:t>docker compose up --build 한 번으로 실적 시드 → 모델 등록 → 계약 테스트 → 서빙까지 이미지 안에서 끝난다</a:t>
+              <a:t>docker compose up --build 한 번으로 시드 → 등록 → 테스트 → 서빙까지 이미지 안에서 끝난다 (Mac, 2026-10-02)</a:t>
             </a:r>
             <a:endParaRPr lang="en-US" sz="1400" dirty="0"/>
           </a:p>
@@ -25543,43 +25543,40 @@
           </a:p>
         </p:txBody>
       </p:sp>
-      <p:sp>
-        <p:nvSpPr>
-          <p:cNvPr id="7" name="Shape 4"/>
-          <p:cNvSpPr/>
-          <p:nvPr/>
-        </p:nvSpPr>
-        <p:spPr>
-          <a:xfrm>
-            <a:off x="548640" y="1554480"/>
-            <a:ext cx="3566160" cy="2788920"/>
-          </a:xfrm>
-          <a:prstGeom prst="roundRect">
-            <a:avLst>
-              <a:gd name="adj" fmla="val 3279"/>
-            </a:avLst>
-          </a:prstGeom>
-          <a:solidFill>
-            <a:srgbClr val="F3F5F9"/>
-          </a:solidFill>
-          <a:ln w="12700">
-            <a:solidFill>
-              <a:srgbClr val="8A8F9A"/>
-            </a:solidFill>
-            <a:prstDash val="sysDash"/>
-          </a:ln>
-        </p:spPr>
-      </p:sp>
-      <p:sp>
-        <p:nvSpPr>
-          <p:cNvPr id="8" name="Text 5"/>
+      <p:pic>
+        <p:nvPicPr>
+          <p:cNvPr id="7" name="Image 0" descr="preencoded.png">    </p:cNvPr>
+          <p:cNvPicPr>
+            <a:picLocks noChangeAspect="1"/>
+          </p:cNvPicPr>
+          <p:nvPr/>
+        </p:nvPicPr>
+        <p:blipFill>
+          <a:blip r:embed="rId1"/>
+          <a:stretch>
+            <a:fillRect/>
+          </a:stretch>
+        </p:blipFill>
+        <p:spPr>
+          <a:xfrm>
+            <a:off x="651914" y="1554480"/>
+            <a:ext cx="3359613" cy="2788920"/>
+          </a:xfrm>
+          <a:prstGeom prst="rect">
+            <a:avLst/>
+          </a:prstGeom>
+        </p:spPr>
+      </p:pic>
+      <p:sp>
+        <p:nvSpPr>
+          <p:cNvPr id="8" name="Text 4"/>
           <p:cNvSpPr txBox="1"/>
           <p:nvPr/>
         </p:nvSpPr>
         <p:spPr>
           <a:xfrm>
-            <a:off x="822960" y="2606040"/>
-            <a:ext cx="3017520" cy="365760"/>
+            <a:off x="548640" y="4434840"/>
+            <a:ext cx="3566160" cy="320040"/>
           </a:xfrm>
           <a:prstGeom prst="rect">
             <a:avLst/>
@@ -25591,34 +25588,97 @@
           <a:bodyPr wrap="square" lIns="0" tIns="0" rIns="0" bIns="0" rtlCol="0" anchor="t"/>
           <a:lstStyle/>
           <a:p>
-            <a:pPr algn="ctr" indent="0" marL="0">
+            <a:pPr indent="0" marL="0">
               <a:buNone/>
             </a:pPr>
             <a:r>
-              <a:rPr lang="en-US" sz="1300" b="1" dirty="0">
-                <a:solidFill>
-                  <a:srgbClr val="8A8F9A"/>
+              <a:rPr lang="en-US" sz="950" b="1" dirty="0">
+                <a:solidFill>
+                  <a:srgbClr val="2A78D6"/>
+                </a:solidFill>
+                <a:latin typeface="Consolas" pitchFamily="34" charset="0"/>
+                <a:ea typeface="Consolas" pitchFamily="34" charset="-122"/>
+                <a:cs typeface="Consolas" pitchFamily="34" charset="-120"/>
+              </a:rPr>
+              <a:t>docker compose -f serving_app/docker-compose.yml up --build</a:t>
+            </a:r>
+            <a:endParaRPr lang="en-US" sz="950" dirty="0"/>
+          </a:p>
+        </p:txBody>
+      </p:sp>
+      <p:sp>
+        <p:nvSpPr>
+          <p:cNvPr id="9" name="Text 5"/>
+          <p:cNvSpPr txBox="1"/>
+          <p:nvPr/>
+        </p:nvSpPr>
+        <p:spPr>
+          <a:xfrm>
+            <a:off x="548640" y="4754880"/>
+            <a:ext cx="3566160" cy="502920"/>
+          </a:xfrm>
+          <a:prstGeom prst="rect">
+            <a:avLst/>
+          </a:prstGeom>
+          <a:noFill/>
+          <a:ln/>
+        </p:spPr>
+        <p:txBody>
+          <a:bodyPr wrap="square" lIns="0" tIns="0" rIns="0" bIns="0" rtlCol="0" anchor="t"/>
+          <a:lstStyle/>
+          <a:p>
+            <a:pPr indent="0" marL="0">
+              <a:buNone/>
+            </a:pPr>
+            <a:r>
+              <a:rPr lang="en-US" sz="1050" dirty="0">
+                <a:solidFill>
+                  <a:srgbClr val="52514E"/>
                 </a:solidFill>
                 <a:latin typeface="Malgun Gothic" pitchFamily="34" charset="0"/>
                 <a:ea typeface="Malgun Gothic" pitchFamily="34" charset="-122"/>
                 <a:cs typeface="Malgun Gothic" pitchFamily="34" charset="-120"/>
               </a:rPr>
-              <a:t>Mac에서 캡처해 넣는 자리</a:t>
-            </a:r>
-            <a:endParaRPr lang="en-US" sz="1300" dirty="0"/>
-          </a:p>
-        </p:txBody>
-      </p:sp>
-      <p:sp>
-        <p:nvSpPr>
-          <p:cNvPr id="9" name="Text 6"/>
+              <a:t>이미지 빌드 87.6초 → [eager] model loaded in 0.576s → Uvicorn running :8010. 아래 GET /health 줄이 HEALTHCHECK</a:t>
+            </a:r>
+            <a:endParaRPr lang="en-US" sz="1050" dirty="0"/>
+          </a:p>
+        </p:txBody>
+      </p:sp>
+      <p:pic>
+        <p:nvPicPr>
+          <p:cNvPr id="10" name="Image 1" descr="preencoded.png">    </p:cNvPr>
+          <p:cNvPicPr>
+            <a:picLocks noChangeAspect="1"/>
+          </p:cNvPicPr>
+          <p:nvPr/>
+        </p:nvPicPr>
+        <p:blipFill>
+          <a:blip r:embed="rId2"/>
+          <a:stretch>
+            <a:fillRect/>
+          </a:stretch>
+        </p:blipFill>
+        <p:spPr>
+          <a:xfrm>
+            <a:off x="4297680" y="1554480"/>
+            <a:ext cx="3566160" cy="926697"/>
+          </a:xfrm>
+          <a:prstGeom prst="rect">
+            <a:avLst/>
+          </a:prstGeom>
+        </p:spPr>
+      </p:pic>
+      <p:sp>
+        <p:nvSpPr>
+          <p:cNvPr id="11" name="Text 6"/>
           <p:cNvSpPr txBox="1"/>
           <p:nvPr/>
         </p:nvSpPr>
         <p:spPr>
           <a:xfrm>
-            <a:off x="822960" y="2971800"/>
-            <a:ext cx="3017520" cy="274320"/>
+            <a:off x="4297680" y="4434840"/>
+            <a:ext cx="3566160" cy="320040"/>
           </a:xfrm>
           <a:prstGeom prst="rect">
             <a:avLst/>
@@ -25630,33 +25690,96 @@
           <a:bodyPr wrap="square" lIns="0" tIns="0" rIns="0" bIns="0" rtlCol="0" anchor="t"/>
           <a:lstStyle/>
           <a:p>
-            <a:pPr algn="ctr" indent="0" marL="0">
+            <a:pPr indent="0" marL="0">
               <a:buNone/>
             </a:pPr>
             <a:r>
-              <a:rPr lang="en-US" sz="1000" dirty="0">
-                <a:solidFill>
-                  <a:srgbClr val="8A8F9A"/>
+              <a:rPr lang="en-US" sz="950" b="1" dirty="0">
+                <a:solidFill>
+                  <a:srgbClr val="2A78D6"/>
                 </a:solidFill>
                 <a:latin typeface="Consolas" pitchFamily="34" charset="0"/>
                 <a:ea typeface="Consolas" pitchFamily="34" charset="-122"/>
                 <a:cs typeface="Consolas" pitchFamily="34" charset="-120"/>
               </a:rPr>
-              <a:t>shots/docker_01.png</a:t>
-            </a:r>
-            <a:endParaRPr lang="en-US" sz="1000" dirty="0"/>
-          </a:p>
-        </p:txBody>
-      </p:sp>
-      <p:sp>
-        <p:nvSpPr>
-          <p:cNvPr id="10" name="Text 7"/>
+              <a:t>docker ps</a:t>
+            </a:r>
+            <a:endParaRPr lang="en-US" sz="950" dirty="0"/>
+          </a:p>
+        </p:txBody>
+      </p:sp>
+      <p:sp>
+        <p:nvSpPr>
+          <p:cNvPr id="12" name="Text 7"/>
           <p:cNvSpPr txBox="1"/>
           <p:nvPr/>
         </p:nvSpPr>
         <p:spPr>
           <a:xfrm>
-            <a:off x="548640" y="4434840"/>
+            <a:off x="4297680" y="4754880"/>
+            <a:ext cx="3566160" cy="502920"/>
+          </a:xfrm>
+          <a:prstGeom prst="rect">
+            <a:avLst/>
+          </a:prstGeom>
+          <a:noFill/>
+          <a:ln/>
+        </p:spPr>
+        <p:txBody>
+          <a:bodyPr wrap="square" lIns="0" tIns="0" rIns="0" bIns="0" rtlCol="0" anchor="t"/>
+          <a:lstStyle/>
+          <a:p>
+            <a:pPr indent="0" marL="0">
+              <a:buNone/>
+            </a:pPr>
+            <a:r>
+              <a:rPr lang="en-US" sz="1050" dirty="0">
+                <a:solidFill>
+                  <a:srgbClr val="52514E"/>
+                </a:solidFill>
+                <a:latin typeface="Malgun Gothic" pitchFamily="34" charset="0"/>
+                <a:ea typeface="Malgun Gothic" pitchFamily="34" charset="-122"/>
+                <a:cs typeface="Malgun Gothic" pitchFamily="34" charset="-120"/>
+              </a:rPr>
+              <a:t>Up 58 seconds (healthy). HEALTHCHECK가 /health의 model_loaded=true까지 확인한 뒤에야 healthy</a:t>
+            </a:r>
+            <a:endParaRPr lang="en-US" sz="1050" dirty="0"/>
+          </a:p>
+        </p:txBody>
+      </p:sp>
+      <p:pic>
+        <p:nvPicPr>
+          <p:cNvPr id="13" name="Image 2" descr="preencoded.png">    </p:cNvPr>
+          <p:cNvPicPr>
+            <a:picLocks noChangeAspect="1"/>
+          </p:cNvPicPr>
+          <p:nvPr/>
+        </p:nvPicPr>
+        <p:blipFill>
+          <a:blip r:embed="rId3"/>
+          <a:stretch>
+            <a:fillRect/>
+          </a:stretch>
+        </p:blipFill>
+        <p:spPr>
+          <a:xfrm>
+            <a:off x="8436656" y="1554480"/>
+            <a:ext cx="2786289" cy="2788920"/>
+          </a:xfrm>
+          <a:prstGeom prst="rect">
+            <a:avLst/>
+          </a:prstGeom>
+        </p:spPr>
+      </p:pic>
+      <p:sp>
+        <p:nvSpPr>
+          <p:cNvPr id="14" name="Text 8"/>
+          <p:cNvSpPr txBox="1"/>
+          <p:nvPr/>
+        </p:nvSpPr>
+        <p:spPr>
+          <a:xfrm>
+            <a:off x="8046720" y="4434840"/>
             <a:ext cx="3566160" cy="320040"/>
           </a:xfrm>
           <a:prstGeom prst="rect">
@@ -25681,7 +25804,7 @@
                 <a:ea typeface="Consolas" pitchFamily="34" charset="-122"/>
                 <a:cs typeface="Consolas" pitchFamily="34" charset="-120"/>
               </a:rPr>
-              <a:t>docker compose -f serving_app/docker-compose.yml up --build</a:t>
+              <a:t>http://localhost:8010/docs (컨테이너)</a:t>
             </a:r>
             <a:endParaRPr lang="en-US" sz="950" dirty="0"/>
           </a:p>
@@ -25689,13 +25812,13 @@
       </p:sp>
       <p:sp>
         <p:nvSpPr>
-          <p:cNvPr id="11" name="Text 8"/>
+          <p:cNvPr id="15" name="Text 9"/>
           <p:cNvSpPr txBox="1"/>
           <p:nvPr/>
         </p:nvSpPr>
         <p:spPr>
           <a:xfrm>
-            <a:off x="548640" y="4754880"/>
+            <a:off x="8046720" y="4754880"/>
             <a:ext cx="3566160" cy="502920"/>
           </a:xfrm>
           <a:prstGeom prst="rect">
@@ -25720,373 +25843,7 @@
                 <a:ea typeface="Malgun Gothic" pitchFamily="34" charset="-122"/>
                 <a:cs typeface="Malgun Gothic" pitchFamily="34" charset="-120"/>
               </a:rPr>
-              <a:t>빌드 로그: [GATE PASSED] · 14 passed · Uvicorn running on 0.0.0.0:8010</a:t>
-            </a:r>
-            <a:endParaRPr lang="en-US" sz="1050" dirty="0"/>
-          </a:p>
-        </p:txBody>
-      </p:sp>
-      <p:sp>
-        <p:nvSpPr>
-          <p:cNvPr id="12" name="Shape 9"/>
-          <p:cNvSpPr/>
-          <p:nvPr/>
-        </p:nvSpPr>
-        <p:spPr>
-          <a:xfrm>
-            <a:off x="4297680" y="1554480"/>
-            <a:ext cx="3566160" cy="2788920"/>
-          </a:xfrm>
-          <a:prstGeom prst="roundRect">
-            <a:avLst>
-              <a:gd name="adj" fmla="val 3279"/>
-            </a:avLst>
-          </a:prstGeom>
-          <a:solidFill>
-            <a:srgbClr val="F3F5F9"/>
-          </a:solidFill>
-          <a:ln w="12700">
-            <a:solidFill>
-              <a:srgbClr val="8A8F9A"/>
-            </a:solidFill>
-            <a:prstDash val="sysDash"/>
-          </a:ln>
-        </p:spPr>
-      </p:sp>
-      <p:sp>
-        <p:nvSpPr>
-          <p:cNvPr id="13" name="Text 10"/>
-          <p:cNvSpPr txBox="1"/>
-          <p:nvPr/>
-        </p:nvSpPr>
-        <p:spPr>
-          <a:xfrm>
-            <a:off x="4572000" y="2606040"/>
-            <a:ext cx="3017520" cy="365760"/>
-          </a:xfrm>
-          <a:prstGeom prst="rect">
-            <a:avLst/>
-          </a:prstGeom>
-          <a:noFill/>
-          <a:ln/>
-        </p:spPr>
-        <p:txBody>
-          <a:bodyPr wrap="square" lIns="0" tIns="0" rIns="0" bIns="0" rtlCol="0" anchor="t"/>
-          <a:lstStyle/>
-          <a:p>
-            <a:pPr algn="ctr" indent="0" marL="0">
-              <a:buNone/>
-            </a:pPr>
-            <a:r>
-              <a:rPr lang="en-US" sz="1300" b="1" dirty="0">
-                <a:solidFill>
-                  <a:srgbClr val="8A8F9A"/>
-                </a:solidFill>
-                <a:latin typeface="Malgun Gothic" pitchFamily="34" charset="0"/>
-                <a:ea typeface="Malgun Gothic" pitchFamily="34" charset="-122"/>
-                <a:cs typeface="Malgun Gothic" pitchFamily="34" charset="-120"/>
-              </a:rPr>
-              <a:t>Mac에서 캡처해 넣는 자리</a:t>
-            </a:r>
-            <a:endParaRPr lang="en-US" sz="1300" dirty="0"/>
-          </a:p>
-        </p:txBody>
-      </p:sp>
-      <p:sp>
-        <p:nvSpPr>
-          <p:cNvPr id="14" name="Text 11"/>
-          <p:cNvSpPr txBox="1"/>
-          <p:nvPr/>
-        </p:nvSpPr>
-        <p:spPr>
-          <a:xfrm>
-            <a:off x="4572000" y="2971800"/>
-            <a:ext cx="3017520" cy="274320"/>
-          </a:xfrm>
-          <a:prstGeom prst="rect">
-            <a:avLst/>
-          </a:prstGeom>
-          <a:noFill/>
-          <a:ln/>
-        </p:spPr>
-        <p:txBody>
-          <a:bodyPr wrap="square" lIns="0" tIns="0" rIns="0" bIns="0" rtlCol="0" anchor="t"/>
-          <a:lstStyle/>
-          <a:p>
-            <a:pPr algn="ctr" indent="0" marL="0">
-              <a:buNone/>
-            </a:pPr>
-            <a:r>
-              <a:rPr lang="en-US" sz="1000" dirty="0">
-                <a:solidFill>
-                  <a:srgbClr val="8A8F9A"/>
-                </a:solidFill>
-                <a:latin typeface="Consolas" pitchFamily="34" charset="0"/>
-                <a:ea typeface="Consolas" pitchFamily="34" charset="-122"/>
-                <a:cs typeface="Consolas" pitchFamily="34" charset="-120"/>
-              </a:rPr>
-              <a:t>shots/docker_02.png</a:t>
-            </a:r>
-            <a:endParaRPr lang="en-US" sz="1000" dirty="0"/>
-          </a:p>
-        </p:txBody>
-      </p:sp>
-      <p:sp>
-        <p:nvSpPr>
-          <p:cNvPr id="15" name="Text 12"/>
-          <p:cNvSpPr txBox="1"/>
-          <p:nvPr/>
-        </p:nvSpPr>
-        <p:spPr>
-          <a:xfrm>
-            <a:off x="4297680" y="4434840"/>
-            <a:ext cx="3566160" cy="320040"/>
-          </a:xfrm>
-          <a:prstGeom prst="rect">
-            <a:avLst/>
-          </a:prstGeom>
-          <a:noFill/>
-          <a:ln/>
-        </p:spPr>
-        <p:txBody>
-          <a:bodyPr wrap="square" lIns="0" tIns="0" rIns="0" bIns="0" rtlCol="0" anchor="t"/>
-          <a:lstStyle/>
-          <a:p>
-            <a:pPr indent="0" marL="0">
-              <a:buNone/>
-            </a:pPr>
-            <a:r>
-              <a:rPr lang="en-US" sz="950" b="1" dirty="0">
-                <a:solidFill>
-                  <a:srgbClr val="2A78D6"/>
-                </a:solidFill>
-                <a:latin typeface="Consolas" pitchFamily="34" charset="0"/>
-                <a:ea typeface="Consolas" pitchFamily="34" charset="-122"/>
-                <a:cs typeface="Consolas" pitchFamily="34" charset="-120"/>
-              </a:rPr>
-              <a:t>docker ps</a:t>
-            </a:r>
-            <a:endParaRPr lang="en-US" sz="950" dirty="0"/>
-          </a:p>
-        </p:txBody>
-      </p:sp>
-      <p:sp>
-        <p:nvSpPr>
-          <p:cNvPr id="16" name="Text 13"/>
-          <p:cNvSpPr txBox="1"/>
-          <p:nvPr/>
-        </p:nvSpPr>
-        <p:spPr>
-          <a:xfrm>
-            <a:off x="4297680" y="4754880"/>
-            <a:ext cx="3566160" cy="502920"/>
-          </a:xfrm>
-          <a:prstGeom prst="rect">
-            <a:avLst/>
-          </a:prstGeom>
-          <a:noFill/>
-          <a:ln/>
-        </p:spPr>
-        <p:txBody>
-          <a:bodyPr wrap="square" lIns="0" tIns="0" rIns="0" bIns="0" rtlCol="0" anchor="t"/>
-          <a:lstStyle/>
-          <a:p>
-            <a:pPr indent="0" marL="0">
-              <a:buNone/>
-            </a:pPr>
-            <a:r>
-              <a:rPr lang="en-US" sz="1050" dirty="0">
-                <a:solidFill>
-                  <a:srgbClr val="52514E"/>
-                </a:solidFill>
-                <a:latin typeface="Malgun Gothic" pitchFamily="34" charset="0"/>
-                <a:ea typeface="Malgun Gothic" pitchFamily="34" charset="-122"/>
-                <a:cs typeface="Malgun Gothic" pitchFamily="34" charset="-120"/>
-              </a:rPr>
-              <a:t>STATUS = healthy (HEALTHCHECK가 /health의 model_loaded=true까지 확인)</a:t>
-            </a:r>
-            <a:endParaRPr lang="en-US" sz="1050" dirty="0"/>
-          </a:p>
-        </p:txBody>
-      </p:sp>
-      <p:sp>
-        <p:nvSpPr>
-          <p:cNvPr id="17" name="Shape 14"/>
-          <p:cNvSpPr/>
-          <p:nvPr/>
-        </p:nvSpPr>
-        <p:spPr>
-          <a:xfrm>
-            <a:off x="8046720" y="1554480"/>
-            <a:ext cx="3566160" cy="2788920"/>
-          </a:xfrm>
-          <a:prstGeom prst="roundRect">
-            <a:avLst>
-              <a:gd name="adj" fmla="val 3279"/>
-            </a:avLst>
-          </a:prstGeom>
-          <a:solidFill>
-            <a:srgbClr val="F3F5F9"/>
-          </a:solidFill>
-          <a:ln w="12700">
-            <a:solidFill>
-              <a:srgbClr val="8A8F9A"/>
-            </a:solidFill>
-            <a:prstDash val="sysDash"/>
-          </a:ln>
-        </p:spPr>
-      </p:sp>
-      <p:sp>
-        <p:nvSpPr>
-          <p:cNvPr id="18" name="Text 15"/>
-          <p:cNvSpPr txBox="1"/>
-          <p:nvPr/>
-        </p:nvSpPr>
-        <p:spPr>
-          <a:xfrm>
-            <a:off x="8321040" y="2606040"/>
-            <a:ext cx="3017520" cy="365760"/>
-          </a:xfrm>
-          <a:prstGeom prst="rect">
-            <a:avLst/>
-          </a:prstGeom>
-          <a:noFill/>
-          <a:ln/>
-        </p:spPr>
-        <p:txBody>
-          <a:bodyPr wrap="square" lIns="0" tIns="0" rIns="0" bIns="0" rtlCol="0" anchor="t"/>
-          <a:lstStyle/>
-          <a:p>
-            <a:pPr algn="ctr" indent="0" marL="0">
-              <a:buNone/>
-            </a:pPr>
-            <a:r>
-              <a:rPr lang="en-US" sz="1300" b="1" dirty="0">
-                <a:solidFill>
-                  <a:srgbClr val="8A8F9A"/>
-                </a:solidFill>
-                <a:latin typeface="Malgun Gothic" pitchFamily="34" charset="0"/>
-                <a:ea typeface="Malgun Gothic" pitchFamily="34" charset="-122"/>
-                <a:cs typeface="Malgun Gothic" pitchFamily="34" charset="-120"/>
-              </a:rPr>
-              <a:t>Mac에서 캡처해 넣는 자리</a:t>
-            </a:r>
-            <a:endParaRPr lang="en-US" sz="1300" dirty="0"/>
-          </a:p>
-        </p:txBody>
-      </p:sp>
-      <p:sp>
-        <p:nvSpPr>
-          <p:cNvPr id="19" name="Text 16"/>
-          <p:cNvSpPr txBox="1"/>
-          <p:nvPr/>
-        </p:nvSpPr>
-        <p:spPr>
-          <a:xfrm>
-            <a:off x="8321040" y="2971800"/>
-            <a:ext cx="3017520" cy="274320"/>
-          </a:xfrm>
-          <a:prstGeom prst="rect">
-            <a:avLst/>
-          </a:prstGeom>
-          <a:noFill/>
-          <a:ln/>
-        </p:spPr>
-        <p:txBody>
-          <a:bodyPr wrap="square" lIns="0" tIns="0" rIns="0" bIns="0" rtlCol="0" anchor="t"/>
-          <a:lstStyle/>
-          <a:p>
-            <a:pPr algn="ctr" indent="0" marL="0">
-              <a:buNone/>
-            </a:pPr>
-            <a:r>
-              <a:rPr lang="en-US" sz="1000" dirty="0">
-                <a:solidFill>
-                  <a:srgbClr val="8A8F9A"/>
-                </a:solidFill>
-                <a:latin typeface="Consolas" pitchFamily="34" charset="0"/>
-                <a:ea typeface="Consolas" pitchFamily="34" charset="-122"/>
-                <a:cs typeface="Consolas" pitchFamily="34" charset="-120"/>
-              </a:rPr>
-              <a:t>shots/docker_03.png</a:t>
-            </a:r>
-            <a:endParaRPr lang="en-US" sz="1000" dirty="0"/>
-          </a:p>
-        </p:txBody>
-      </p:sp>
-      <p:sp>
-        <p:nvSpPr>
-          <p:cNvPr id="20" name="Text 17"/>
-          <p:cNvSpPr txBox="1"/>
-          <p:nvPr/>
-        </p:nvSpPr>
-        <p:spPr>
-          <a:xfrm>
-            <a:off x="8046720" y="4434840"/>
-            <a:ext cx="3566160" cy="320040"/>
-          </a:xfrm>
-          <a:prstGeom prst="rect">
-            <a:avLst/>
-          </a:prstGeom>
-          <a:noFill/>
-          <a:ln/>
-        </p:spPr>
-        <p:txBody>
-          <a:bodyPr wrap="square" lIns="0" tIns="0" rIns="0" bIns="0" rtlCol="0" anchor="t"/>
-          <a:lstStyle/>
-          <a:p>
-            <a:pPr indent="0" marL="0">
-              <a:buNone/>
-            </a:pPr>
-            <a:r>
-              <a:rPr lang="en-US" sz="950" b="1" dirty="0">
-                <a:solidFill>
-                  <a:srgbClr val="2A78D6"/>
-                </a:solidFill>
-                <a:latin typeface="Consolas" pitchFamily="34" charset="0"/>
-                <a:ea typeface="Consolas" pitchFamily="34" charset="-122"/>
-                <a:cs typeface="Consolas" pitchFamily="34" charset="-120"/>
-              </a:rPr>
-              <a:t>http://localhost:8010/docs (컨테이너)</a:t>
-            </a:r>
-            <a:endParaRPr lang="en-US" sz="950" dirty="0"/>
-          </a:p>
-        </p:txBody>
-      </p:sp>
-      <p:sp>
-        <p:nvSpPr>
-          <p:cNvPr id="21" name="Text 18"/>
-          <p:cNvSpPr txBox="1"/>
-          <p:nvPr/>
-        </p:nvSpPr>
-        <p:spPr>
-          <a:xfrm>
-            <a:off x="8046720" y="4754880"/>
-            <a:ext cx="3566160" cy="502920"/>
-          </a:xfrm>
-          <a:prstGeom prst="rect">
-            <a:avLst/>
-          </a:prstGeom>
-          <a:noFill/>
-          <a:ln/>
-        </p:spPr>
-        <p:txBody>
-          <a:bodyPr wrap="square" lIns="0" tIns="0" rIns="0" bIns="0" rtlCol="0" anchor="t"/>
-          <a:lstStyle/>
-          <a:p>
-            <a:pPr indent="0" marL="0">
-              <a:buNone/>
-            </a:pPr>
-            <a:r>
-              <a:rPr lang="en-US" sz="1050" dirty="0">
-                <a:solidFill>
-                  <a:srgbClr val="52514E"/>
-                </a:solidFill>
-                <a:latin typeface="Malgun Gothic" pitchFamily="34" charset="0"/>
-                <a:ea typeface="Malgun Gothic" pitchFamily="34" charset="-122"/>
-                <a:cs typeface="Malgun Gothic" pitchFamily="34" charset="-120"/>
-              </a:rPr>
-              <a:t>/predict Try it out → 200, model_version production-v1</a:t>
+              <a:t>tests/sample_predict_request.json 을 보내 200. 로컬과 같은 3,649.7 kWh, production-v1</a:t>
             </a:r>
             <a:endParaRPr lang="en-US" sz="1050" dirty="0"/>
           </a:p>

</xml_diff>